<commit_message>
Update presentation deck and strategy documentation
Remove internal notes from the presentation deck, regenerate PDF and PPTX files, and add a new strategy document outlining next steps.

Replit-Commit-Author: Agent
Replit-Commit-Session-Id: ce089693-6854-4324-93b2-95f77a9759f4
Replit-Commit-Checkpoint-Type: full_checkpoint
Replit-Commit-Event-Id: c837778b-61fd-4bb0-b596-870b313936a7
Replit-Commit-Screenshot-Url: https://storage.googleapis.com/screenshot-production-us-central1/ceb23eaa-0ec0-4109-a10a-5e37190a0ad7/ce089693-6854-4324-93b2-95f77a9759f4/AZnF6a8
Replit-Helium-Checkpoint-Created: true
</commit_message>
<xml_diff>
--- a/attached_assets/timeline-deck-slides/dime-time-timeline-deck.pptx
+++ b/attached_assets/timeline-deck-slides/dime-time-timeline-deck.pptx
@@ -10072,45 +10072,6 @@
                 <a:latin typeface="Poppins"/>
               </a:rPr>
               <a:t>A first iOS app (“Dime Time Technologies”) starts taking shape — ~60 commits of work that won't survive the year.</a:t>
-            </a:r>
-          </a:p>
-        </p:txBody>
-      </p:sp>
-      <p:sp>
-        <p:nvSpPr>
-          <p:cNvPr id="8" name="TextBox 7"/>
-          <p:cNvSpPr txBox="1"/>
-          <p:nvPr/>
-        </p:nvSpPr>
-        <p:spPr>
-          <a:xfrm>
-            <a:off x="685800" y="5943600"/>
-            <a:ext cx="10789920" cy="548640"/>
-          </a:xfrm>
-          <a:prstGeom prst="rect">
-            <a:avLst/>
-          </a:prstGeom>
-          <a:noFill/>
-        </p:spPr>
-        <p:txBody>
-          <a:bodyPr wrap="square">
-            <a:spAutoFit/>
-          </a:bodyPr>
-          <a:lstStyle/>
-          <a:p>
-            <a:pPr algn="l">
-              <a:spcAft>
-                <a:spcPts val="600"/>
-              </a:spcAft>
-            </a:pPr>
-            <a:r>
-              <a:rPr sz="1300" b="0">
-                <a:solidFill>
-                  <a:srgbClr val="4A468F"/>
-                </a:solidFill>
-                <a:latin typeface="Poppins"/>
-              </a:rPr>
-              <a:t>Tip for the live talk: drop an early app screenshot here — primitive beginnings make the finished product hit harder.</a:t>
             </a:r>
           </a:p>
         </p:txBody>

</xml_diff>

<commit_message>
Update pitch and timeline decks with new financial data and visuals
Update pitch deck slides 9 and 10 with latest facts, and refresh timeline deck commit counts and payout dates.

Replit-Commit-Author: Agent
Replit-Commit-Session-Id: ce089693-6854-4324-93b2-95f77a9759f4
Replit-Commit-Checkpoint-Type: full_checkpoint
Replit-Commit-Event-Id: c7808b18-ed54-426e-8368-a0edb1725eb5
Replit-Commit-Screenshot-Url: https://storage.googleapis.com/screenshot-production-us-central1/ceb23eaa-0ec0-4109-a10a-5e37190a0ad7/ce089693-6854-4324-93b2-95f77a9759f4/a5OVRQu
Replit-Helium-Checkpoint-Created: true
</commit_message>
<xml_diff>
--- a/attached_assets/timeline-deck-slides/dime-time-timeline-deck.pptx
+++ b/attached_assets/timeline-deck-slides/dime-time-timeline-deck.pptx
@@ -3771,7 +3771,7 @@
                 </a:solidFill>
                 <a:latin typeface="Poppins"/>
               </a:rPr>
-              <a:t>137</a:t>
+              <a:t>254</a:t>
             </a:r>
           </a:p>
           <a:p>
@@ -4303,7 +4303,7 @@
                 </a:solidFill>
                 <a:latin typeface="Poppins"/>
               </a:rPr>
-              <a:t>July 7–8: initiated  •  July 13–14: settled  •  July 15: payout landed in Mercury</a:t>
+              <a:t>July 7–8: initiated  •  July 13–14: settled  •  July 20: $0.99 payout confirmed in Mercury</a:t>
             </a:r>
           </a:p>
           <a:p>
@@ -4319,7 +4319,7 @@
                 </a:solidFill>
                 <a:latin typeface="Poppins"/>
               </a:rPr>
-              <a:t>Also this month: v1.0.4 redesign approved by Apple, admin money controls, automatic debt import built, AI-readable web guides.</a:t>
+              <a:t>Also this month: v1.0.5 approved &amp; live on the App Store, Google Play account opened, admin money controls, automatic debt import built.</a:t>
             </a:r>
           </a:p>
           <a:p>
@@ -4335,7 +4335,7 @@
                 </a:solidFill>
                 <a:latin typeface="Poppins"/>
               </a:rPr>
-              <a:t>The machine works — proven with real money, 346 days after the first commit.</a:t>
+              <a:t>The machine works — proven bank-to-bank with real money, 351 days after the first commit.</a:t>
             </a:r>
           </a:p>
         </p:txBody>
@@ -4975,7 +4975,7 @@
                 </a:solidFill>
                 <a:latin typeface="Poppins"/>
               </a:rPr>
-              <a:t>✓  USPTO — provisional patent drafted</a:t>
+              <a:t>✓  USPTO — provisional patent filed (pending)</a:t>
             </a:r>
           </a:p>
           <a:p>
@@ -5784,7 +5784,7 @@
                 </a:solidFill>
                 <a:latin typeface="Poppins"/>
               </a:rPr>
-              <a:t>1,160+</a:t>
+              <a:t>1,216</a:t>
             </a:r>
           </a:p>
           <a:p>
@@ -6760,7 +6760,7 @@
                 </a:solidFill>
                 <a:latin typeface="Poppins"/>
               </a:rPr>
-              <a:t>Near-term: automatic debt import in production  •  first paying subscribers ($2.99/mo)  •  the public launch announcement.</a:t>
+              <a:t>In motion now: Google Play launch prep  •  Stripe Financial Connections &amp; Plaid Liabilities under review  •  first paying subscribers ($2.99/mo)  •  the public launch announcement.</a:t>
             </a:r>
           </a:p>
           <a:p>
@@ -7493,7 +7493,7 @@
                 </a:solidFill>
                 <a:latin typeface="Poppins"/>
               </a:rPr>
-              <a:t>1,099 commits, month by month</a:t>
+              <a:t>1,216 commits, month by month</a:t>
             </a:r>
           </a:p>
         </p:txBody>
@@ -7506,8 +7506,8 @@
         </p:nvSpPr>
         <p:spPr>
           <a:xfrm>
-            <a:off x="990904" y="3429443"/>
-            <a:ext cx="548030" cy="1599756"/>
+            <a:off x="990904" y="3731760"/>
+            <a:ext cx="548030" cy="1297440"/>
           </a:xfrm>
           <a:prstGeom prst="roundRect">
             <a:avLst/>
@@ -7550,7 +7550,7 @@
         </p:nvSpPr>
         <p:spPr>
           <a:xfrm>
-            <a:off x="808024" y="3045395"/>
+            <a:off x="808024" y="3347712"/>
             <a:ext cx="913790" cy="365760"/>
           </a:xfrm>
           <a:prstGeom prst="rect">
@@ -7628,8 +7628,8 @@
         </p:nvSpPr>
         <p:spPr>
           <a:xfrm>
-            <a:off x="1874824" y="1920240"/>
-            <a:ext cx="548030" cy="3108960"/>
+            <a:off x="1874824" y="2507760"/>
+            <a:ext cx="548030" cy="2521440"/>
           </a:xfrm>
           <a:prstGeom prst="roundRect">
             <a:avLst/>
@@ -7672,7 +7672,7 @@
         </p:nvSpPr>
         <p:spPr>
           <a:xfrm>
-            <a:off x="1691944" y="1536192"/>
+            <a:off x="1691944" y="2123712"/>
             <a:ext cx="913790" cy="365760"/>
           </a:xfrm>
           <a:prstGeom prst="rect">
@@ -7750,8 +7750,8 @@
         </p:nvSpPr>
         <p:spPr>
           <a:xfrm>
-            <a:off x="2758744" y="3444535"/>
-            <a:ext cx="548030" cy="1584664"/>
+            <a:off x="2758744" y="3744000"/>
+            <a:ext cx="548030" cy="1285200"/>
           </a:xfrm>
           <a:prstGeom prst="roundRect">
             <a:avLst/>
@@ -7794,7 +7794,7 @@
         </p:nvSpPr>
         <p:spPr>
           <a:xfrm>
-            <a:off x="2575864" y="3060487"/>
+            <a:off x="2575864" y="3359952"/>
             <a:ext cx="913790" cy="365760"/>
           </a:xfrm>
           <a:prstGeom prst="rect">
@@ -7872,8 +7872,8 @@
         </p:nvSpPr>
         <p:spPr>
           <a:xfrm>
-            <a:off x="3642664" y="3112511"/>
-            <a:ext cx="548030" cy="1916688"/>
+            <a:off x="3642664" y="3474720"/>
+            <a:ext cx="548030" cy="1554480"/>
           </a:xfrm>
           <a:prstGeom prst="roundRect">
             <a:avLst/>
@@ -7916,7 +7916,7 @@
         </p:nvSpPr>
         <p:spPr>
           <a:xfrm>
-            <a:off x="3459784" y="2728463"/>
+            <a:off x="3459784" y="3090672"/>
             <a:ext cx="913790" cy="365760"/>
           </a:xfrm>
           <a:prstGeom prst="rect">
@@ -7994,8 +7994,8 @@
         </p:nvSpPr>
         <p:spPr>
           <a:xfrm>
-            <a:off x="4526584" y="2916314"/>
-            <a:ext cx="548030" cy="2112885"/>
+            <a:off x="4526584" y="3315600"/>
+            <a:ext cx="548030" cy="1713600"/>
           </a:xfrm>
           <a:prstGeom prst="roundRect">
             <a:avLst/>
@@ -8038,7 +8038,7 @@
         </p:nvSpPr>
         <p:spPr>
           <a:xfrm>
-            <a:off x="4343704" y="2532266"/>
+            <a:off x="4343704" y="2931552"/>
             <a:ext cx="913790" cy="365760"/>
           </a:xfrm>
           <a:prstGeom prst="rect">
@@ -8116,8 +8116,8 @@
         </p:nvSpPr>
         <p:spPr>
           <a:xfrm>
-            <a:off x="5410504" y="4712267"/>
-            <a:ext cx="548030" cy="316932"/>
+            <a:off x="5410504" y="4772160"/>
+            <a:ext cx="548030" cy="257040"/>
           </a:xfrm>
           <a:prstGeom prst="roundRect">
             <a:avLst/>
@@ -8160,7 +8160,7 @@
         </p:nvSpPr>
         <p:spPr>
           <a:xfrm>
-            <a:off x="5227624" y="4328219"/>
+            <a:off x="5227624" y="4388112"/>
             <a:ext cx="913790" cy="365760"/>
           </a:xfrm>
           <a:prstGeom prst="rect">
@@ -8238,8 +8238,8 @@
         </p:nvSpPr>
         <p:spPr>
           <a:xfrm>
-            <a:off x="6294424" y="4833003"/>
-            <a:ext cx="548030" cy="196196"/>
+            <a:off x="6294424" y="4870080"/>
+            <a:ext cx="548030" cy="159120"/>
           </a:xfrm>
           <a:prstGeom prst="roundRect">
             <a:avLst/>
@@ -8282,7 +8282,7 @@
         </p:nvSpPr>
         <p:spPr>
           <a:xfrm>
-            <a:off x="6111544" y="4448955"/>
+            <a:off x="6111544" y="4486032"/>
             <a:ext cx="913790" cy="365760"/>
           </a:xfrm>
           <a:prstGeom prst="rect">
@@ -8360,8 +8360,8 @@
         </p:nvSpPr>
         <p:spPr>
           <a:xfrm>
-            <a:off x="7178344" y="4561346"/>
-            <a:ext cx="548030" cy="467853"/>
+            <a:off x="7178344" y="4649760"/>
+            <a:ext cx="548030" cy="379440"/>
           </a:xfrm>
           <a:prstGeom prst="roundRect">
             <a:avLst/>
@@ -8404,7 +8404,7 @@
         </p:nvSpPr>
         <p:spPr>
           <a:xfrm>
-            <a:off x="6995464" y="4177298"/>
+            <a:off x="6995464" y="4265712"/>
             <a:ext cx="913790" cy="365760"/>
           </a:xfrm>
           <a:prstGeom prst="rect">
@@ -8482,8 +8482,8 @@
         </p:nvSpPr>
         <p:spPr>
           <a:xfrm>
-            <a:off x="8062264" y="4440610"/>
-            <a:ext cx="548030" cy="588589"/>
+            <a:off x="8062264" y="4551840"/>
+            <a:ext cx="548030" cy="477360"/>
           </a:xfrm>
           <a:prstGeom prst="roundRect">
             <a:avLst/>
@@ -8526,7 +8526,7 @@
         </p:nvSpPr>
         <p:spPr>
           <a:xfrm>
-            <a:off x="7879384" y="4056562"/>
+            <a:off x="7879384" y="4167792"/>
             <a:ext cx="913790" cy="365760"/>
           </a:xfrm>
           <a:prstGeom prst="rect">
@@ -8604,8 +8604,8 @@
         </p:nvSpPr>
         <p:spPr>
           <a:xfrm>
-            <a:off x="8946184" y="3987849"/>
-            <a:ext cx="548030" cy="1041350"/>
+            <a:off x="8946184" y="4184639"/>
+            <a:ext cx="548030" cy="844560"/>
           </a:xfrm>
           <a:prstGeom prst="roundRect">
             <a:avLst/>
@@ -8648,7 +8648,7 @@
         </p:nvSpPr>
         <p:spPr>
           <a:xfrm>
-            <a:off x="8763304" y="3603801"/>
+            <a:off x="8763304" y="3800592"/>
             <a:ext cx="913790" cy="365760"/>
           </a:xfrm>
           <a:prstGeom prst="rect">
@@ -8726,8 +8726,8 @@
         </p:nvSpPr>
         <p:spPr>
           <a:xfrm>
-            <a:off x="9830104" y="3444535"/>
-            <a:ext cx="548030" cy="1584664"/>
+            <a:off x="9830104" y="3744000"/>
+            <a:ext cx="548030" cy="1285200"/>
           </a:xfrm>
           <a:prstGeom prst="roundRect">
             <a:avLst/>
@@ -8770,7 +8770,7 @@
         </p:nvSpPr>
         <p:spPr>
           <a:xfrm>
-            <a:off x="9647224" y="3060487"/>
+            <a:off x="9647224" y="3359952"/>
             <a:ext cx="913790" cy="365760"/>
           </a:xfrm>
           <a:prstGeom prst="rect">
@@ -8848,8 +8848,8 @@
         </p:nvSpPr>
         <p:spPr>
           <a:xfrm>
-            <a:off x="10714024" y="2961590"/>
-            <a:ext cx="548030" cy="2067609"/>
+            <a:off x="10714024" y="1920240"/>
+            <a:ext cx="548030" cy="3108960"/>
           </a:xfrm>
           <a:prstGeom prst="roundRect">
             <a:avLst/>
@@ -8892,7 +8892,7 @@
         </p:nvSpPr>
         <p:spPr>
           <a:xfrm>
-            <a:off x="10531144" y="2577542"/>
+            <a:off x="10531144" y="1536192"/>
             <a:ext cx="913790" cy="365760"/>
           </a:xfrm>
           <a:prstGeom prst="rect">
@@ -8918,7 +8918,7 @@
                 </a:solidFill>
                 <a:latin typeface="Poppins"/>
               </a:rPr>
-              <a:t>137</a:t>
+              <a:t>254</a:t>
             </a:r>
           </a:p>
         </p:txBody>

</xml_diff>